<commit_message>
Translate and clean report and presentation, remove external references
</commit_message>
<xml_diff>
--- a/report/diagrams.pptx
+++ b/report/diagrams.pptx
@@ -8,6 +8,7 @@
     <p:notesMasterId r:id="rId4"/>
   </p:notesMasterIdLst>
   <p:sldIdLst>
+    <p:sldId id="265" r:id="rId9"/>
     <p:sldId id="263" r:id="rId2"/>
     <p:sldId id="264" r:id="rId3"/>
   </p:sldIdLst>
@@ -3903,7 +3904,7 @@
                 <a:latin typeface="Times New Roman" panose="02020603050405020304" pitchFamily="18" charset="0"/>
                 <a:ea typeface="宋体" panose="02010600030101010101" pitchFamily="2" charset="-122"/>
               </a:rPr>
-              <a:t>示例数据</a:t>
+              <a:t>Sample IMU Data</a:t>
             </a:r>
           </a:p>
         </p:txBody>
@@ -4024,7 +4025,7 @@
                       <a:latin typeface="宋体" panose="02010600030101010101" pitchFamily="2" charset="-122"/>
                       <a:ea typeface="宋体" panose="02010600030101010101" pitchFamily="2" charset="-122"/>
                     </a:rPr>
-                    <a:t>更新速度</a:t>
+                    <a:t>Update Velocity</a:t>
                   </a:r>
                   <a:endParaRPr lang="en-US" altLang="zh-CN" sz="1400" b="1" dirty="0">
                     <a:solidFill>
@@ -4152,7 +4153,7 @@
                       <a:latin typeface="宋体" panose="02010600030101010101" pitchFamily="2" charset="-122"/>
                       <a:ea typeface="宋体" panose="02010600030101010101" pitchFamily="2" charset="-122"/>
                     </a:rPr>
-                    <a:t>更新位置</a:t>
+                    <a:t>Update Position</a:t>
                   </a:r>
                   <a:endParaRPr lang="en-US" altLang="zh-CN" sz="1400" b="1" dirty="0">
                     <a:solidFill>
@@ -4280,7 +4281,7 @@
                       <a:latin typeface="宋体" panose="02010600030101010101" pitchFamily="2" charset="-122"/>
                       <a:ea typeface="宋体" panose="02010600030101010101" pitchFamily="2" charset="-122"/>
                     </a:rPr>
-                    <a:t>更新姿态</a:t>
+                    <a:t>Update Attitude</a:t>
                   </a:r>
                   <a:endParaRPr lang="en-US" altLang="zh-CN" sz="1400" b="1" dirty="0">
                     <a:solidFill>
@@ -4472,7 +4473,7 @@
                 <a:latin typeface="宋体" panose="02010600030101010101" pitchFamily="2" charset="-122"/>
                 <a:ea typeface="宋体" panose="02010600030101010101" pitchFamily="2" charset="-122"/>
               </a:rPr>
-              <a:t>调试</a:t>
+              <a:t>Debug &amp; Verify</a:t>
             </a:r>
           </a:p>
         </p:txBody>
@@ -4533,7 +4534,7 @@
                 <a:latin typeface="宋体" panose="02010600030101010101" pitchFamily="2" charset="-122"/>
                 <a:ea typeface="宋体" panose="02010600030101010101" pitchFamily="2" charset="-122"/>
               </a:rPr>
-              <a:t>满足要求</a:t>
+              <a:t>Criteria Met?</a:t>
             </a:r>
           </a:p>
         </p:txBody>
@@ -4662,7 +4663,7 @@
                 <a:latin typeface="宋体" panose="02010600030101010101" pitchFamily="2" charset="-122"/>
                 <a:ea typeface="宋体" panose="02010600030101010101" pitchFamily="2" charset="-122"/>
               </a:rPr>
-              <a:t>否</a:t>
+              <a:t>No</a:t>
             </a:r>
           </a:p>
         </p:txBody>
@@ -4723,7 +4724,7 @@
                 <a:latin typeface="Times New Roman" panose="02020603050405020304" pitchFamily="18" charset="0"/>
                 <a:ea typeface="宋体" panose="02010600030101010101" pitchFamily="2" charset="-122"/>
               </a:rPr>
-              <a:t>自采数据</a:t>
+              <a:t>Field IMU Data</a:t>
             </a:r>
           </a:p>
         </p:txBody>
@@ -4844,7 +4845,7 @@
                       <a:latin typeface="宋体" panose="02010600030101010101" pitchFamily="2" charset="-122"/>
                       <a:ea typeface="宋体" panose="02010600030101010101" pitchFamily="2" charset="-122"/>
                     </a:rPr>
-                    <a:t>更新速度</a:t>
+                    <a:t>Update Velocity</a:t>
                   </a:r>
                   <a:endParaRPr lang="en-US" altLang="zh-CN" sz="1400" b="1" dirty="0">
                     <a:solidFill>
@@ -4972,7 +4973,7 @@
                       <a:latin typeface="宋体" panose="02010600030101010101" pitchFamily="2" charset="-122"/>
                       <a:ea typeface="宋体" panose="02010600030101010101" pitchFamily="2" charset="-122"/>
                     </a:rPr>
-                    <a:t>更新位置</a:t>
+                    <a:t>Update Position</a:t>
                   </a:r>
                   <a:endParaRPr lang="en-US" altLang="zh-CN" sz="1400" b="1" dirty="0">
                     <a:solidFill>
@@ -5100,7 +5101,7 @@
                       <a:latin typeface="宋体" panose="02010600030101010101" pitchFamily="2" charset="-122"/>
                       <a:ea typeface="宋体" panose="02010600030101010101" pitchFamily="2" charset="-122"/>
                     </a:rPr>
-                    <a:t>更新姿态</a:t>
+                    <a:t>Update Attitude</a:t>
                   </a:r>
                   <a:endParaRPr lang="en-US" altLang="zh-CN" sz="1400" b="1" dirty="0">
                     <a:solidFill>
@@ -5291,7 +5292,7 @@
                 <a:latin typeface="宋体" panose="02010600030101010101" pitchFamily="2" charset="-122"/>
                 <a:ea typeface="宋体" panose="02010600030101010101" pitchFamily="2" charset="-122"/>
               </a:rPr>
-              <a:t>是</a:t>
+              <a:t>Yes</a:t>
             </a:r>
           </a:p>
         </p:txBody>
@@ -5444,7 +5445,7 @@
                 <a:latin typeface="宋体" panose="02010600030101010101" pitchFamily="2" charset="-122"/>
                 <a:ea typeface="宋体" panose="02010600030101010101" pitchFamily="2" charset="-122"/>
               </a:rPr>
-              <a:t>助教解算</a:t>
+              <a:t>Reference Solution</a:t>
             </a:r>
             <a:endParaRPr lang="en-US" altLang="zh-CN" sz="1400" b="1" dirty="0">
               <a:solidFill>
@@ -5512,7 +5513,7 @@
                 <a:latin typeface="宋体" panose="02010600030101010101" pitchFamily="2" charset="-122"/>
                 <a:ea typeface="宋体" panose="02010600030101010101" pitchFamily="2" charset="-122"/>
               </a:rPr>
-              <a:t>评估与分析</a:t>
+              <a:t>Evaluation &amp; Analysis</a:t>
             </a:r>
             <a:endParaRPr lang="en-US" altLang="zh-CN" sz="1400" b="1" dirty="0">
               <a:solidFill>
@@ -5646,7 +5647,7 @@
                 <a:latin typeface="宋体" panose="02010600030101010101" pitchFamily="2" charset="-122"/>
                 <a:ea typeface="宋体" panose="02010600030101010101" pitchFamily="2" charset="-122"/>
               </a:rPr>
-              <a:t>参考真值</a:t>
+              <a:t>Ground Truth</a:t>
             </a:r>
           </a:p>
         </p:txBody>
@@ -5725,7 +5726,7 @@
                 <a:latin typeface="宋体" panose="02010600030101010101" pitchFamily="2" charset="-122"/>
                 <a:ea typeface="宋体" panose="02010600030101010101" pitchFamily="2" charset="-122"/>
               </a:rPr>
-              <a:t>零速修正</a:t>
+              <a:t>ZUPT Correction</a:t>
             </a:r>
           </a:p>
         </p:txBody>
@@ -5816,7 +5817,7 @@
                 <a:latin typeface="Times New Roman" panose="02020603050405020304" pitchFamily="18" charset="0"/>
                 <a:ea typeface="宋体" panose="02010600030101010101" pitchFamily="2" charset="-122"/>
               </a:rPr>
-              <a:t>示例数据 </a:t>
+              <a:t>Sample IMU Data </a:t>
             </a:r>
             <a:r>
               <a:rPr lang="en-US" altLang="zh-CN" sz="1400" b="1" dirty="0">
@@ -5836,7 +5837,7 @@
                 <a:latin typeface="Times New Roman" panose="02020603050405020304" pitchFamily="18" charset="0"/>
                 <a:ea typeface="宋体" panose="02010600030101010101" pitchFamily="2" charset="-122"/>
               </a:rPr>
-              <a:t>自采数据</a:t>
+              <a:t>Field IMU Data</a:t>
             </a:r>
           </a:p>
         </p:txBody>
@@ -5943,7 +5944,7 @@
                 <a:latin typeface="Times New Roman" panose="02020603050405020304" pitchFamily="18" charset="0"/>
                 <a:ea typeface="宋体" panose="02010600030101010101" pitchFamily="2" charset="-122"/>
               </a:rPr>
-              <a:t>参考真值</a:t>
+              <a:t>Ground Truth</a:t>
             </a:r>
           </a:p>
         </p:txBody>
@@ -6070,7 +6071,7 @@
                 <a:latin typeface="宋体" panose="02010600030101010101" pitchFamily="2" charset="-122"/>
                 <a:ea typeface="宋体" panose="02010600030101010101" pitchFamily="2" charset="-122"/>
               </a:rPr>
-              <a:t>零速修正</a:t>
+              <a:t>ZUPT Correction</a:t>
             </a:r>
           </a:p>
         </p:txBody>
@@ -6325,7 +6326,7 @@
                       <a:latin typeface="宋体" panose="02010600030101010101" pitchFamily="2" charset="-122"/>
                       <a:ea typeface="宋体" panose="02010600030101010101" pitchFamily="2" charset="-122"/>
                     </a:rPr>
-                    <a:t>统一变量单位</a:t>
+                    <a:t>Standardize Units</a:t>
                   </a:r>
                   <a:endParaRPr lang="en-US" altLang="zh-CN" sz="1400" b="1" dirty="0">
                     <a:solidFill>
@@ -6496,7 +6497,7 @@
                 <a:latin typeface="宋体" panose="02010600030101010101" pitchFamily="2" charset="-122"/>
                 <a:ea typeface="宋体" panose="02010600030101010101" pitchFamily="2" charset="-122"/>
               </a:rPr>
-              <a:t>读取一行</a:t>
+              <a:t>Read IMU Epoch</a:t>
             </a:r>
           </a:p>
         </p:txBody>
@@ -6636,7 +6637,7 @@
                     <a:latin typeface="宋体" panose="02010600030101010101" pitchFamily="2" charset="-122"/>
                     <a:ea typeface="宋体" panose="02010600030101010101" pitchFamily="2" charset="-122"/>
                   </a:rPr>
-                  <a:t>速度更新</a:t>
+                  <a:t>Velocity Update</a:t>
                 </a:r>
                 <a:endParaRPr lang="en-US" altLang="zh-CN" sz="1400" b="1" dirty="0">
                   <a:solidFill>
@@ -6796,7 +6797,7 @@
                     <a:latin typeface="宋体" panose="02010600030101010101" pitchFamily="2" charset="-122"/>
                     <a:ea typeface="宋体" panose="02010600030101010101" pitchFamily="2" charset="-122"/>
                   </a:rPr>
-                  <a:t>位置更新</a:t>
+                  <a:t>Position Update</a:t>
                 </a:r>
                 <a:endParaRPr lang="en-US" altLang="zh-CN" sz="1400" b="1" dirty="0">
                   <a:solidFill>
@@ -6994,7 +6995,7 @@
                     <a:latin typeface="宋体" panose="02010600030101010101" pitchFamily="2" charset="-122"/>
                     <a:ea typeface="宋体" panose="02010600030101010101" pitchFamily="2" charset="-122"/>
                   </a:rPr>
-                  <a:t>姿态更新</a:t>
+                  <a:t>Attitude Update</a:t>
                 </a:r>
                 <a:endParaRPr lang="en-US" altLang="zh-CN" sz="1400" b="1" dirty="0">
                   <a:solidFill>
@@ -7240,7 +7241,7 @@
                     <a:latin typeface="Times New Roman" panose="02020603050405020304" pitchFamily="18" charset="0"/>
                     <a:ea typeface="宋体" panose="02010600030101010101" pitchFamily="2" charset="-122"/>
                   </a:rPr>
-                  <a:t>速度</a:t>
+                  <a:t>Velocity</a:t>
                 </a:r>
               </a:p>
             </p:txBody>
@@ -7373,7 +7374,7 @@
                     <a:latin typeface="Times New Roman" panose="02020603050405020304" pitchFamily="18" charset="0"/>
                     <a:ea typeface="宋体" panose="02010600030101010101" pitchFamily="2" charset="-122"/>
                   </a:rPr>
-                  <a:t>速度</a:t>
+                  <a:t>Velocity</a:t>
                 </a:r>
               </a:p>
             </p:txBody>
@@ -8097,7 +8098,7 @@
                       <a:latin typeface="Times New Roman" panose="02020603050405020304" pitchFamily="18" charset="0"/>
                       <a:ea typeface="宋体" panose="02010600030101010101" pitchFamily="2" charset="-122"/>
                     </a:rPr>
-                    <a:t>位置</a:t>
+                    <a:t>Position</a:t>
                   </a:r>
                 </a:p>
               </p:txBody>
@@ -8230,7 +8231,7 @@
                       <a:latin typeface="Times New Roman" panose="02020603050405020304" pitchFamily="18" charset="0"/>
                       <a:ea typeface="宋体" panose="02010600030101010101" pitchFamily="2" charset="-122"/>
                     </a:rPr>
-                    <a:t>位置</a:t>
+                    <a:t>Position</a:t>
                   </a:r>
                 </a:p>
               </p:txBody>
@@ -8422,7 +8423,7 @@
                     <a:latin typeface="Times New Roman" panose="02020603050405020304" pitchFamily="18" charset="0"/>
                     <a:ea typeface="宋体" panose="02010600030101010101" pitchFamily="2" charset="-122"/>
                   </a:rPr>
-                  <a:t>姿态</a:t>
+                  <a:t>Attitude</a:t>
                 </a:r>
               </a:p>
             </p:txBody>
@@ -8634,7 +8635,7 @@
                     <a:latin typeface="Times New Roman" panose="02020603050405020304" pitchFamily="18" charset="0"/>
                     <a:ea typeface="宋体" panose="02010600030101010101" pitchFamily="2" charset="-122"/>
                   </a:rPr>
-                  <a:t>速度</a:t>
+                  <a:t>Velocity</a:t>
                 </a:r>
               </a:p>
             </p:txBody>
@@ -9306,7 +9307,7 @@
                       <a:latin typeface="Times New Roman" panose="02020603050405020304" pitchFamily="18" charset="0"/>
                       <a:ea typeface="宋体" panose="02010600030101010101" pitchFamily="2" charset="-122"/>
                     </a:rPr>
-                    <a:t>位置</a:t>
+                    <a:t>Position</a:t>
                   </a:r>
                 </a:p>
               </p:txBody>
@@ -9439,7 +9440,7 @@
                       <a:latin typeface="Times New Roman" panose="02020603050405020304" pitchFamily="18" charset="0"/>
                       <a:ea typeface="宋体" panose="02010600030101010101" pitchFamily="2" charset="-122"/>
                     </a:rPr>
-                    <a:t>位置</a:t>
+                    <a:t>Position</a:t>
                   </a:r>
                 </a:p>
               </p:txBody>
@@ -9757,7 +9758,7 @@
                     <a:latin typeface="Times New Roman" panose="02020603050405020304" pitchFamily="18" charset="0"/>
                     <a:ea typeface="宋体" panose="02010600030101010101" pitchFamily="2" charset="-122"/>
                   </a:rPr>
-                  <a:t>速度</a:t>
+                  <a:t>Velocity</a:t>
                 </a:r>
               </a:p>
             </p:txBody>
@@ -10409,7 +10410,7 @@
                     <a:latin typeface="Times New Roman" panose="02020603050405020304" pitchFamily="18" charset="0"/>
                     <a:ea typeface="宋体" panose="02010600030101010101" pitchFamily="2" charset="-122"/>
                   </a:rPr>
-                  <a:t>位置</a:t>
+                  <a:t>Position</a:t>
                 </a:r>
               </a:p>
             </p:txBody>
@@ -10627,7 +10628,7 @@
                 <a:latin typeface="宋体" panose="02010600030101010101" pitchFamily="2" charset="-122"/>
                 <a:ea typeface="宋体" panose="02010600030101010101" pitchFamily="2" charset="-122"/>
               </a:rPr>
-              <a:t>精度评定</a:t>
+              <a:t>Accuracy Assessment</a:t>
             </a:r>
           </a:p>
         </p:txBody>
@@ -10665,7 +10666,7 @@
                 <a:latin typeface="宋体" panose="02010600030101010101" pitchFamily="2" charset="-122"/>
                 <a:ea typeface="宋体" panose="02010600030101010101" pitchFamily="2" charset="-122"/>
               </a:rPr>
-              <a:t>零速修正</a:t>
+              <a:t>ZUPT Correction</a:t>
             </a:r>
           </a:p>
         </p:txBody>
@@ -10765,6 +10766,142 @@
         <p14:creationId xmlns:p14="http://schemas.microsoft.com/office/powerpoint/2010/main" val="3900913585"/>
       </p:ext>
     </p:extLst>
+  </p:cSld>
+  <p:clrMapOvr>
+    <a:masterClrMapping/>
+  </p:clrMapOvr>
+</p:sld>
+</file>
+
+<file path=ppt/slides/slide3.xml><?xml version="1.0" encoding="utf-8"?>
+<p:sld xmlns:a="http://schemas.openxmlformats.org/drawingml/2006/main" xmlns:p="http://schemas.openxmlformats.org/presentationml/2006/main" xmlns:r="http://schemas.openxmlformats.org/officeDocument/2006/relationships">
+  <p:cSld>
+    <p:spTree>
+      <p:nvGrpSpPr>
+        <p:cNvPr id="1" name=""/>
+        <p:cNvGrpSpPr/>
+        <p:nvPr/>
+      </p:nvGrpSpPr>
+      <p:grpSpPr/>
+      <p:sp>
+        <p:nvSpPr>
+          <p:cNvPr id="2" name="TextBox 1"/>
+          <p:cNvSpPr txBox="1"/>
+          <p:nvPr/>
+        </p:nvSpPr>
+        <p:spPr>
+          <a:xfrm>
+            <a:off x="731520" y="1371600"/>
+            <a:ext cx="7680960" cy="1828800"/>
+          </a:xfrm>
+          <a:prstGeom prst="rect">
+            <a:avLst/>
+          </a:prstGeom>
+          <a:noFill/>
+        </p:spPr>
+        <p:txBody>
+          <a:bodyPr wrap="square">
+            <a:spAutoFit/>
+          </a:bodyPr>
+          <a:lstStyle/>
+          <a:p>
+            <a:pPr algn="ctr">
+              <a:defRPr sz="3600" b="1">
+                <a:solidFill>
+                  <a:srgbClr val="182B49"/>
+                </a:solidFill>
+              </a:defRPr>
+            </a:pPr>
+            <a:r>
+              <a:t>INS_Mechanization</a:t>
+            </a:r>
+          </a:p>
+          <a:p>
+            <a:pPr algn="ctr">
+              <a:defRPr sz="2000">
+                <a:solidFill>
+                  <a:srgbClr val="46505F"/>
+                </a:solidFill>
+              </a:defRPr>
+            </a:pPr>
+            <a:r>
+              <a:t>Inertial Navigation System Mechanization &amp; Trajectory Analysis</a:t>
+            </a:r>
+          </a:p>
+        </p:txBody>
+      </p:sp>
+      <p:sp>
+        <p:nvSpPr>
+          <p:cNvPr id="3" name="TextBox 2"/>
+          <p:cNvSpPr txBox="1"/>
+          <p:nvPr/>
+        </p:nvSpPr>
+        <p:spPr>
+          <a:xfrm>
+            <a:off x="914400" y="3474720"/>
+            <a:ext cx="7315200" cy="1828800"/>
+          </a:xfrm>
+          <a:prstGeom prst="rect">
+            <a:avLst/>
+          </a:prstGeom>
+          <a:noFill/>
+        </p:spPr>
+        <p:txBody>
+          <a:bodyPr wrap="square">
+            <a:spAutoFit/>
+          </a:bodyPr>
+          <a:lstStyle/>
+          <a:p>
+            <a:pPr algn="ctr">
+              <a:defRPr sz="2000" b="1">
+                <a:solidFill>
+                  <a:srgbClr val="1E2837"/>
+                </a:solidFill>
+              </a:defRPr>
+            </a:pPr>
+            <a:r>
+              <a:t>Mohammed Hsiny</a:t>
+            </a:r>
+          </a:p>
+          <a:p>
+            <a:pPr algn="ctr">
+              <a:defRPr sz="1500">
+                <a:solidFill>
+                  <a:srgbClr val="505A64"/>
+                </a:solidFill>
+              </a:defRPr>
+            </a:pPr>
+            <a:r>
+              <a:t>Electrical Engineering &amp; Industrial Control Student</a:t>
+            </a:r>
+          </a:p>
+          <a:p>
+            <a:pPr algn="ctr">
+              <a:defRPr sz="1500">
+                <a:solidFill>
+                  <a:srgbClr val="505A64"/>
+                </a:solidFill>
+              </a:defRPr>
+            </a:pPr>
+            <a:r>
+              <a:t>Faculty of Sciences and Techniques of Mohammedia</a:t>
+            </a:r>
+          </a:p>
+          <a:p>
+            <a:pPr algn="ctr">
+              <a:defRPr sz="1300" i="1">
+                <a:solidFill>
+                  <a:srgbClr val="6E7882"/>
+                </a:solidFill>
+              </a:defRPr>
+            </a:pPr>
+            <a:r>
+              <a:t>Year: 2026</a:t>
+            </a:r>
+          </a:p>
+        </p:txBody>
+      </p:sp>
+    </p:spTree>
   </p:cSld>
   <p:clrMapOvr>
     <a:masterClrMapping/>

</xml_diff>